<commit_message>
Extended deck: paper title on the title slide; drop the 'Note' label from bubbles
Co-Authored-By: Claude Opus 5.5 <noreply@anthropic.com>
</commit_message>
<xml_diff>
--- a/presentations/module2_extended_presentation.pptx
+++ b/presentations/module2_extended_presentation.pptx
@@ -1292,7 +1292,7 @@
           <a:lstStyle/>
           <a:p>
             <a:r>
-              <a:t>The deck moves from physics to data to AI to engineering value. Yellow bubbles like this one carry the presenter's explanation for each slide; the same text is in the speaker notes. Every number shown later is read from the executed results, not typed by hand.</a:t>
+              <a:t>The deck moves from physics to data to AI to engineering value. Yellow bubbles like this one explain each slide in plain words. Every number shown later is read from the executed results, not typed by hand.</a:t>
             </a:r>
           </a:p>
         </p:txBody>
@@ -5001,7 +5001,7 @@
                 </a:solidFill>
                 <a:latin typeface="Calibri"/>
               </a:rPr>
-              <a:t>Fast, explainable antenna screening with AI</a:t>
+              <a:t/>
             </a:r>
           </a:p>
         </p:txBody>
@@ -5084,8 +5084,8 @@
         </p:nvSpPr>
         <p:spPr>
           <a:xfrm>
-            <a:off x="548640" y="1371600"/>
-            <a:ext cx="10789920" cy="914400"/>
+            <a:off x="548640" y="640080"/>
+            <a:ext cx="11064240" cy="1188720"/>
           </a:xfrm>
           <a:prstGeom prst="rect">
             <a:avLst/>
@@ -5100,27 +5100,62 @@
           <a:p>
             <a:pPr algn="l"/>
             <a:r>
-              <a:rPr sz="1800" b="0">
+              <a:rPr sz="3200" b="1">
+                <a:solidFill>
+                  <a:srgbClr val="FFFFFF"/>
+                </a:solidFill>
+                <a:latin typeface="Calibri"/>
+              </a:rPr>
+              <a:t>Numerical-Text Surrogate Modelling and Multi-Objective Optimisation of Compact Patch Antennas</a:t>
+            </a:r>
+          </a:p>
+        </p:txBody>
+      </p:sp>
+      <p:sp>
+        <p:nvSpPr>
+          <p:cNvPr id="7" name="TextBox 6"/>
+          <p:cNvSpPr txBox="1"/>
+          <p:nvPr/>
+        </p:nvSpPr>
+        <p:spPr>
+          <a:xfrm>
+            <a:off x="548640" y="1874519"/>
+            <a:ext cx="11064240" cy="822960"/>
+          </a:xfrm>
+          <a:prstGeom prst="rect">
+            <a:avLst/>
+          </a:prstGeom>
+          <a:noFill/>
+        </p:spPr>
+        <p:txBody>
+          <a:bodyPr wrap="square" anchor="t" lIns="45720" rIns="45720">
+            <a:spAutoFit/>
+          </a:bodyPr>
+          <a:lstStyle/>
+          <a:p>
+            <a:pPr algn="l"/>
+            <a:r>
+              <a:rPr sz="1700" b="0">
                 <a:solidFill>
                   <a:srgbClr val="CFE2F3"/>
                 </a:solidFill>
                 <a:latin typeface="Calibri"/>
               </a:rPr>
-              <a:t>Module 2 - Numerical-Text Surrogate Modelling, Multimodal Fusion and NSGA-II Optimisation of Compact Patch Antennas for 5G and Emerging 6G Networks (extended presentation)</a:t>
-            </a:r>
-          </a:p>
-        </p:txBody>
-      </p:sp>
-      <p:sp>
-        <p:nvSpPr>
-          <p:cNvPr id="7" name="Rounded Rectangle 6"/>
+              <a:t>Module 2 of the Applied Vision Transformer Framework for Hybrid-Slotted DGS Compact Patch Antenna Design: HFSS-Driven Multi-Objective Optimization for 5G and Emerging 6G Networks</a:t>
+            </a:r>
+          </a:p>
+        </p:txBody>
+      </p:sp>
+      <p:sp>
+        <p:nvSpPr>
+          <p:cNvPr id="8" name="Rounded Rectangle 7"/>
           <p:cNvSpPr/>
           <p:nvPr/>
         </p:nvSpPr>
         <p:spPr>
           <a:xfrm>
-            <a:off x="548640" y="2514600"/>
-            <a:ext cx="2606040" cy="1417320"/>
+            <a:off x="548640" y="2834640"/>
+            <a:ext cx="2606040" cy="1325880"/>
           </a:xfrm>
           <a:prstGeom prst="roundRect">
             <a:avLst>
@@ -5159,13 +5194,13 @@
       </p:sp>
       <p:sp>
         <p:nvSpPr>
-          <p:cNvPr id="8" name="TextBox 7"/>
+          <p:cNvPr id="9" name="TextBox 8"/>
           <p:cNvSpPr txBox="1"/>
           <p:nvPr/>
         </p:nvSpPr>
         <p:spPr>
           <a:xfrm>
-            <a:off x="731520" y="2606040"/>
+            <a:off x="731520" y="2898648"/>
             <a:ext cx="2377440" cy="640080"/>
           </a:xfrm>
           <a:prstGeom prst="rect">
@@ -5181,7 +5216,7 @@
           <a:p>
             <a:pPr algn="l"/>
             <a:r>
-              <a:rPr sz="3400" b="1">
+              <a:rPr sz="3200" b="1">
                 <a:solidFill>
                   <a:srgbClr val="FFFFFF"/>
                 </a:solidFill>
@@ -5194,13 +5229,13 @@
       </p:sp>
       <p:sp>
         <p:nvSpPr>
-          <p:cNvPr id="9" name="TextBox 8"/>
+          <p:cNvPr id="10" name="TextBox 9"/>
           <p:cNvSpPr txBox="1"/>
           <p:nvPr/>
         </p:nvSpPr>
         <p:spPr>
           <a:xfrm>
-            <a:off x="731520" y="3291840"/>
+            <a:off x="731520" y="3547872"/>
             <a:ext cx="2377440" cy="548640"/>
           </a:xfrm>
           <a:prstGeom prst="rect">
@@ -5229,14 +5264,14 @@
       </p:sp>
       <p:sp>
         <p:nvSpPr>
-          <p:cNvPr id="10" name="Rounded Rectangle 9"/>
+          <p:cNvPr id="11" name="Rounded Rectangle 10"/>
           <p:cNvSpPr/>
           <p:nvPr/>
         </p:nvSpPr>
         <p:spPr>
           <a:xfrm>
-            <a:off x="3383280" y="2514600"/>
-            <a:ext cx="2606040" cy="1417320"/>
+            <a:off x="3383280" y="2834640"/>
+            <a:ext cx="2606040" cy="1325880"/>
           </a:xfrm>
           <a:prstGeom prst="roundRect">
             <a:avLst>
@@ -5275,13 +5310,13 @@
       </p:sp>
       <p:sp>
         <p:nvSpPr>
-          <p:cNvPr id="11" name="TextBox 10"/>
+          <p:cNvPr id="12" name="TextBox 11"/>
           <p:cNvSpPr txBox="1"/>
           <p:nvPr/>
         </p:nvSpPr>
         <p:spPr>
           <a:xfrm>
-            <a:off x="3566160" y="2606040"/>
+            <a:off x="3566160" y="2898648"/>
             <a:ext cx="2377440" cy="640080"/>
           </a:xfrm>
           <a:prstGeom prst="rect">
@@ -5297,7 +5332,7 @@
           <a:p>
             <a:pPr algn="l"/>
             <a:r>
-              <a:rPr sz="3400" b="1">
+              <a:rPr sz="3200" b="1">
                 <a:solidFill>
                   <a:srgbClr val="FFFFFF"/>
                 </a:solidFill>
@@ -5310,13 +5345,13 @@
       </p:sp>
       <p:sp>
         <p:nvSpPr>
-          <p:cNvPr id="12" name="TextBox 11"/>
+          <p:cNvPr id="13" name="TextBox 12"/>
           <p:cNvSpPr txBox="1"/>
           <p:nvPr/>
         </p:nvSpPr>
         <p:spPr>
           <a:xfrm>
-            <a:off x="3566160" y="3291840"/>
+            <a:off x="3566160" y="3547872"/>
             <a:ext cx="2377440" cy="548640"/>
           </a:xfrm>
           <a:prstGeom prst="rect">
@@ -5345,14 +5380,14 @@
       </p:sp>
       <p:sp>
         <p:nvSpPr>
-          <p:cNvPr id="13" name="Rounded Rectangle 12"/>
+          <p:cNvPr id="14" name="Rounded Rectangle 13"/>
           <p:cNvSpPr/>
           <p:nvPr/>
         </p:nvSpPr>
         <p:spPr>
           <a:xfrm>
-            <a:off x="6217920" y="2514600"/>
-            <a:ext cx="2606040" cy="1417320"/>
+            <a:off x="6217920" y="2834640"/>
+            <a:ext cx="2606040" cy="1325880"/>
           </a:xfrm>
           <a:prstGeom prst="roundRect">
             <a:avLst>
@@ -5391,13 +5426,13 @@
       </p:sp>
       <p:sp>
         <p:nvSpPr>
-          <p:cNvPr id="14" name="TextBox 13"/>
+          <p:cNvPr id="15" name="TextBox 14"/>
           <p:cNvSpPr txBox="1"/>
           <p:nvPr/>
         </p:nvSpPr>
         <p:spPr>
           <a:xfrm>
-            <a:off x="6400800" y="2606040"/>
+            <a:off x="6400800" y="2898648"/>
             <a:ext cx="2377440" cy="640080"/>
           </a:xfrm>
           <a:prstGeom prst="rect">
@@ -5413,7 +5448,7 @@
           <a:p>
             <a:pPr algn="l"/>
             <a:r>
-              <a:rPr sz="3400" b="1">
+              <a:rPr sz="3200" b="1">
                 <a:solidFill>
                   <a:srgbClr val="FFFFFF"/>
                 </a:solidFill>
@@ -5426,13 +5461,13 @@
       </p:sp>
       <p:sp>
         <p:nvSpPr>
-          <p:cNvPr id="15" name="TextBox 14"/>
+          <p:cNvPr id="16" name="TextBox 15"/>
           <p:cNvSpPr txBox="1"/>
           <p:nvPr/>
         </p:nvSpPr>
         <p:spPr>
           <a:xfrm>
-            <a:off x="6400800" y="3291840"/>
+            <a:off x="6400800" y="3547872"/>
             <a:ext cx="2377440" cy="548640"/>
           </a:xfrm>
           <a:prstGeom prst="rect">
@@ -5461,14 +5496,14 @@
       </p:sp>
       <p:sp>
         <p:nvSpPr>
-          <p:cNvPr id="16" name="Rounded Rectangle 15"/>
+          <p:cNvPr id="17" name="Rounded Rectangle 16"/>
           <p:cNvSpPr/>
           <p:nvPr/>
         </p:nvSpPr>
         <p:spPr>
           <a:xfrm>
-            <a:off x="9052560" y="2514600"/>
-            <a:ext cx="2606040" cy="1417320"/>
+            <a:off x="9052560" y="2834640"/>
+            <a:ext cx="2606040" cy="1325880"/>
           </a:xfrm>
           <a:prstGeom prst="roundRect">
             <a:avLst>
@@ -5507,13 +5542,13 @@
       </p:sp>
       <p:sp>
         <p:nvSpPr>
-          <p:cNvPr id="17" name="TextBox 16"/>
+          <p:cNvPr id="18" name="TextBox 17"/>
           <p:cNvSpPr txBox="1"/>
           <p:nvPr/>
         </p:nvSpPr>
         <p:spPr>
           <a:xfrm>
-            <a:off x="9235440" y="2606040"/>
+            <a:off x="9235440" y="2898648"/>
             <a:ext cx="2377440" cy="640080"/>
           </a:xfrm>
           <a:prstGeom prst="rect">
@@ -5529,7 +5564,7 @@
           <a:p>
             <a:pPr algn="l"/>
             <a:r>
-              <a:rPr sz="3400" b="1">
+              <a:rPr sz="3200" b="1">
                 <a:solidFill>
                   <a:srgbClr val="FFFFFF"/>
                 </a:solidFill>
@@ -5542,13 +5577,13 @@
       </p:sp>
       <p:sp>
         <p:nvSpPr>
-          <p:cNvPr id="18" name="TextBox 17"/>
+          <p:cNvPr id="19" name="TextBox 18"/>
           <p:cNvSpPr txBox="1"/>
           <p:nvPr/>
         </p:nvSpPr>
         <p:spPr>
           <a:xfrm>
-            <a:off x="9235440" y="3291840"/>
+            <a:off x="9235440" y="3547872"/>
             <a:ext cx="2377440" cy="548640"/>
           </a:xfrm>
           <a:prstGeom prst="rect">
@@ -5577,13 +5612,13 @@
       </p:sp>
       <p:sp>
         <p:nvSpPr>
-          <p:cNvPr id="19" name="TextBox 18"/>
+          <p:cNvPr id="20" name="TextBox 19"/>
           <p:cNvSpPr txBox="1"/>
           <p:nvPr/>
         </p:nvSpPr>
         <p:spPr>
           <a:xfrm>
-            <a:off x="548640" y="4343400"/>
+            <a:off x="548640" y="4480560"/>
             <a:ext cx="10789920" cy="1097280"/>
           </a:xfrm>
           <a:prstGeom prst="rect">
@@ -6539,14 +6574,14 @@
       </p:graphicFrame>
       <p:sp>
         <p:nvSpPr>
-          <p:cNvPr id="7" name="Note bubble"/>
+          <p:cNvPr id="7" name="Explanation bubble"/>
           <p:cNvSpPr/>
           <p:nvPr/>
         </p:nvSpPr>
         <p:spPr>
           <a:xfrm>
             <a:off x="8641080" y="1417320"/>
-            <a:ext cx="3017520" cy="3566160"/>
+            <a:ext cx="3017520" cy="3342132"/>
           </a:xfrm>
           <a:prstGeom prst="wedgeRoundRectCallout">
             <a:avLst>
@@ -6583,19 +6618,23 @@
           <a:bodyPr rtlCol="0" anchor="t" wrap="square" lIns="164592" rIns="164592" tIns="128016"/>
           <a:lstStyle/>
           <a:p>
-            <a:pPr algn="ctr"/>
-            <a:r>
-              <a:rPr sz="1400" b="1">
-                <a:solidFill>
-                  <a:srgbClr val="8A5A00"/>
-                </a:solidFill>
-                <a:latin typeface="Calibri"/>
-              </a:rPr>
-              <a:t>Note</a:t>
-            </a:r>
-          </a:p>
-          <a:p>
-            <a:pPr>
+            <a:pPr algn="l">
+              <a:spcBef>
+                <a:spcPts val="0"/>
+              </a:spcBef>
+            </a:pPr>
+            <a:r>
+              <a:rPr sz="1300">
+                <a:solidFill>
+                  <a:srgbClr val="0B2A4A"/>
+                </a:solidFill>
+                <a:latin typeface="Calibri"/>
+              </a:rPr>
+              <a:t>These are the features in the machine-learning sense: the numbers the model receives.</a:t>
+            </a:r>
+          </a:p>
+          <a:p>
+            <a:pPr algn="l">
               <a:spcBef>
                 <a:spcPts val="500"/>
               </a:spcBef>
@@ -6607,11 +6646,11 @@
                 </a:solidFill>
                 <a:latin typeface="Calibri"/>
               </a:rPr>
-              <a:t>These are the features in the machine-learning sense: the numbers the model receives.</a:t>
-            </a:r>
-          </a:p>
-          <a:p>
-            <a:pPr>
+              <a:t>Patch models use 5 inputs; the slotted (Mendeley) models use 10 dimensions plus frequency.</a:t>
+            </a:r>
+          </a:p>
+          <a:p>
+            <a:pPr algn="l">
               <a:spcBef>
                 <a:spcPts val="500"/>
               </a:spcBef>
@@ -6623,27 +6662,11 @@
                 </a:solidFill>
                 <a:latin typeface="Calibri"/>
               </a:rPr>
-              <a:t>Patch models use 5 inputs; the slotted (Mendeley) models use 10 dimensions plus frequency.</a:t>
-            </a:r>
-          </a:p>
-          <a:p>
-            <a:pPr>
-              <a:spcBef>
-                <a:spcPts val="500"/>
-              </a:spcBef>
-            </a:pPr>
-            <a:r>
-              <a:rPr sz="1300">
-                <a:solidFill>
-                  <a:srgbClr val="0B2A4A"/>
-                </a:solidFill>
-                <a:latin typeface="Calibri"/>
-              </a:rPr>
               <a:t>Engineered ratios (W/L, feed ratio) encode physics the trees would otherwise have to discover.</a:t>
             </a:r>
           </a:p>
           <a:p>
-            <a:pPr>
+            <a:pPr algn="l">
               <a:spcBef>
                 <a:spcPts val="500"/>
               </a:spcBef>
@@ -7484,14 +7507,14 @@
       </p:pic>
       <p:sp>
         <p:nvSpPr>
-          <p:cNvPr id="23" name="Note bubble"/>
+          <p:cNvPr id="23" name="Explanation bubble"/>
           <p:cNvSpPr/>
           <p:nvPr/>
         </p:nvSpPr>
         <p:spPr>
           <a:xfrm>
             <a:off x="8641080" y="1417320"/>
-            <a:ext cx="3017520" cy="4014215"/>
+            <a:ext cx="3017520" cy="3790188"/>
           </a:xfrm>
           <a:prstGeom prst="wedgeRoundRectCallout">
             <a:avLst>
@@ -7528,19 +7551,23 @@
           <a:bodyPr rtlCol="0" anchor="t" wrap="square" lIns="164592" rIns="164592" tIns="128016"/>
           <a:lstStyle/>
           <a:p>
-            <a:pPr algn="ctr"/>
-            <a:r>
-              <a:rPr sz="1400" b="1">
-                <a:solidFill>
-                  <a:srgbClr val="8A5A00"/>
-                </a:solidFill>
-                <a:latin typeface="Calibri"/>
-              </a:rPr>
-              <a:t>Note</a:t>
-            </a:r>
-          </a:p>
-          <a:p>
-            <a:pPr>
+            <a:pPr algn="l">
+              <a:spcBef>
+                <a:spcPts val="0"/>
+              </a:spcBef>
+            </a:pPr>
+            <a:r>
+              <a:rPr sz="1300">
+                <a:solidFill>
+                  <a:srgbClr val="0B2A4A"/>
+                </a:solidFill>
+                <a:latin typeface="Calibri"/>
+              </a:rPr>
+              <a:t>Vectorisation turns each design into a fixed-length list of numbers.</a:t>
+            </a:r>
+          </a:p>
+          <a:p>
+            <a:pPr algn="l">
               <a:spcBef>
                 <a:spcPts val="500"/>
               </a:spcBef>
@@ -7552,11 +7579,11 @@
                 </a:solidFill>
                 <a:latin typeface="Calibri"/>
               </a:rPr>
-              <a:t>Vectorisation turns each design into a fixed-length list of numbers.</a:t>
-            </a:r>
-          </a:p>
-          <a:p>
-            <a:pPr>
+              <a:t>Linear models and the MLP need standardised inputs (mean 0, SD 1, fitted on training data only); trees do not.</a:t>
+            </a:r>
+          </a:p>
+          <a:p>
+            <a:pPr algn="l">
               <a:spcBef>
                 <a:spcPts val="500"/>
               </a:spcBef>
@@ -7568,27 +7595,11 @@
                 </a:solidFill>
                 <a:latin typeface="Calibri"/>
               </a:rPr>
-              <a:t>Linear models and the MLP need standardised inputs (mean 0, SD 1, fitted on training data only); trees do not.</a:t>
-            </a:r>
-          </a:p>
-          <a:p>
-            <a:pPr>
-              <a:spcBef>
-                <a:spcPts val="500"/>
-              </a:spcBef>
-            </a:pPr>
-            <a:r>
-              <a:rPr sz="1300">
-                <a:solidFill>
-                  <a:srgbClr val="0B2A4A"/>
-                </a:solidFill>
-                <a:latin typeface="Calibri"/>
-              </a:rPr>
               <a:t>For fusion, the 384 image numbers and 5 design numbers are joined into one 389-number vector.</a:t>
             </a:r>
           </a:p>
           <a:p>
-            <a:pPr>
+            <a:pPr algn="l">
               <a:spcBef>
                 <a:spcPts val="500"/>
               </a:spcBef>
@@ -8481,14 +8492,14 @@
       </p:sp>
       <p:sp>
         <p:nvSpPr>
-          <p:cNvPr id="24" name="Note bubble"/>
+          <p:cNvPr id="24" name="Explanation bubble"/>
           <p:cNvSpPr/>
           <p:nvPr/>
         </p:nvSpPr>
         <p:spPr>
           <a:xfrm>
             <a:off x="8641080" y="1417320"/>
-            <a:ext cx="3017520" cy="3790188"/>
+            <a:ext cx="3017520" cy="3566160"/>
           </a:xfrm>
           <a:prstGeom prst="wedgeRoundRectCallout">
             <a:avLst>
@@ -8525,19 +8536,23 @@
           <a:bodyPr rtlCol="0" anchor="t" wrap="square" lIns="164592" rIns="164592" tIns="128016"/>
           <a:lstStyle/>
           <a:p>
-            <a:pPr algn="ctr"/>
-            <a:r>
-              <a:rPr sz="1400" b="1">
-                <a:solidFill>
-                  <a:srgbClr val="8A5A00"/>
-                </a:solidFill>
-                <a:latin typeface="Calibri"/>
-              </a:rPr>
-              <a:t>Note</a:t>
-            </a:r>
-          </a:p>
-          <a:p>
-            <a:pPr>
+            <a:pPr algn="l">
+              <a:spcBef>
+                <a:spcPts val="0"/>
+              </a:spcBef>
+            </a:pPr>
+            <a:r>
+              <a:rPr sz="1300">
+                <a:solidFill>
+                  <a:srgbClr val="0B2A4A"/>
+                </a:solidFill>
+                <a:latin typeface="Calibri"/>
+              </a:rPr>
+              <a:t>Several model families compete; the one with the lowest validation error wins - here the random forest for every target.</a:t>
+            </a:r>
+          </a:p>
+          <a:p>
+            <a:pPr algn="l">
               <a:spcBef>
                 <a:spcPts val="500"/>
               </a:spcBef>
@@ -8549,11 +8564,11 @@
                 </a:solidFill>
                 <a:latin typeface="Calibri"/>
               </a:rPr>
-              <a:t>Several model families compete; the one with the lowest validation error wins - here the random forest for every target.</a:t>
-            </a:r>
-          </a:p>
-          <a:p>
-            <a:pPr>
+              <a:t>The test split is used once, after the choice, so the reported accuracy is not tuned to it.</a:t>
+            </a:r>
+          </a:p>
+          <a:p>
+            <a:pPr algn="l">
               <a:spcBef>
                 <a:spcPts val="500"/>
               </a:spcBef>
@@ -8565,27 +8580,11 @@
                 </a:solidFill>
                 <a:latin typeface="Calibri"/>
               </a:rPr>
-              <a:t>The test split is used once, after the choice, so the reported accuracy is not tuned to it.</a:t>
-            </a:r>
-          </a:p>
-          <a:p>
-            <a:pPr>
-              <a:spcBef>
-                <a:spcPts val="500"/>
-              </a:spcBef>
-            </a:pPr>
-            <a:r>
-              <a:rPr sz="1300">
-                <a:solidFill>
-                  <a:srgbClr val="0B2A4A"/>
-                </a:solidFill>
-                <a:latin typeface="Calibri"/>
-              </a:rPr>
               <a:t>GroupKFold keeps all 16 frequencies of a Mendeley design in the same fold, preventing leakage.</a:t>
             </a:r>
           </a:p>
           <a:p>
-            <a:pPr>
+            <a:pPr algn="l">
               <a:spcBef>
                 <a:spcPts val="500"/>
               </a:spcBef>
@@ -9408,14 +9407,14 @@
       </p:pic>
       <p:sp>
         <p:nvSpPr>
-          <p:cNvPr id="8" name="Note bubble"/>
+          <p:cNvPr id="8" name="Explanation bubble"/>
           <p:cNvSpPr/>
           <p:nvPr/>
         </p:nvSpPr>
         <p:spPr>
           <a:xfrm>
             <a:off x="8641080" y="1417320"/>
-            <a:ext cx="3017520" cy="3790188"/>
+            <a:ext cx="3017520" cy="3566160"/>
           </a:xfrm>
           <a:prstGeom prst="wedgeRoundRectCallout">
             <a:avLst>
@@ -9452,19 +9451,23 @@
           <a:bodyPr rtlCol="0" anchor="t" wrap="square" lIns="164592" rIns="164592" tIns="128016"/>
           <a:lstStyle/>
           <a:p>
-            <a:pPr algn="ctr"/>
-            <a:r>
-              <a:rPr sz="1400" b="1">
-                <a:solidFill>
-                  <a:srgbClr val="8A5A00"/>
-                </a:solidFill>
-                <a:latin typeface="Calibri"/>
-              </a:rPr>
-              <a:t>Note</a:t>
-            </a:r>
-          </a:p>
-          <a:p>
-            <a:pPr>
+            <a:pPr algn="l">
+              <a:spcBef>
+                <a:spcPts val="0"/>
+              </a:spcBef>
+            </a:pPr>
+            <a:r>
+              <a:rPr sz="1300">
+                <a:solidFill>
+                  <a:srgbClr val="0B2A4A"/>
+                </a:solidFill>
+                <a:latin typeface="Calibri"/>
+              </a:rPr>
+              <a:t>Resonance is predicted well (R² 0.89, error 0.35 GHz) and bandwidth well (R² 0.83).</a:t>
+            </a:r>
+          </a:p>
+          <a:p>
+            <a:pPr algn="l">
               <a:spcBef>
                 <a:spcPts val="500"/>
               </a:spcBef>
@@ -9476,11 +9479,11 @@
                 </a:solidFill>
                 <a:latin typeface="Calibri"/>
               </a:rPr>
-              <a:t>Resonance is predicted well (R² 0.89, error 0.35 GHz) and bandwidth well (R² 0.83).</a:t>
-            </a:r>
-          </a:p>
-          <a:p>
-            <a:pPr>
+              <a:t>Matching depth (S11) is harder (R² 0.54) because it changes sharply with feed impedance.</a:t>
+            </a:r>
+          </a:p>
+          <a:p>
+            <a:pPr algn="l">
               <a:spcBef>
                 <a:spcPts val="500"/>
               </a:spcBef>
@@ -9492,27 +9495,11 @@
                 </a:solidFill>
                 <a:latin typeface="Calibri"/>
               </a:rPr>
-              <a:t>Matching depth (S11) is harder (R² 0.54) because it changes sharply with feed impedance.</a:t>
-            </a:r>
-          </a:p>
-          <a:p>
-            <a:pPr>
-              <a:spcBef>
-                <a:spcPts val="500"/>
-              </a:spcBef>
-            </a:pPr>
-            <a:r>
-              <a:rPr sz="1300">
-                <a:solidFill>
-                  <a:srgbClr val="0B2A4A"/>
-                </a:solidFill>
-                <a:latin typeface="Calibri"/>
-              </a:rPr>
               <a:t>On wider, unseen patches (OOD) accuracy collapses - surrogates are only trustworthy inside their training range.</a:t>
             </a:r>
           </a:p>
           <a:p>
-            <a:pPr>
+            <a:pPr algn="l">
               <a:spcBef>
                 <a:spcPts val="500"/>
               </a:spcBef>
@@ -10125,14 +10112,14 @@
       </p:pic>
       <p:sp>
         <p:nvSpPr>
-          <p:cNvPr id="8" name="Note bubble"/>
+          <p:cNvPr id="8" name="Explanation bubble"/>
           <p:cNvSpPr/>
           <p:nvPr/>
         </p:nvSpPr>
         <p:spPr>
           <a:xfrm>
             <a:off x="8641080" y="1417320"/>
-            <a:ext cx="3017520" cy="3707891"/>
+            <a:ext cx="3017520" cy="3483864"/>
           </a:xfrm>
           <a:prstGeom prst="wedgeRoundRectCallout">
             <a:avLst>
@@ -10169,19 +10156,23 @@
           <a:bodyPr rtlCol="0" anchor="t" wrap="square" lIns="164592" rIns="164592" tIns="128016"/>
           <a:lstStyle/>
           <a:p>
-            <a:pPr algn="ctr"/>
-            <a:r>
-              <a:rPr sz="1400" b="1">
-                <a:solidFill>
-                  <a:srgbClr val="8A5A00"/>
-                </a:solidFill>
-                <a:latin typeface="Calibri"/>
-              </a:rPr>
-              <a:t>Note</a:t>
-            </a:r>
-          </a:p>
-          <a:p>
-            <a:pPr>
+            <a:pPr algn="l">
+              <a:spcBef>
+                <a:spcPts val="0"/>
+              </a:spcBef>
+            </a:pPr>
+            <a:r>
+              <a:rPr sz="1300">
+                <a:solidFill>
+                  <a:srgbClr val="0B2A4A"/>
+                </a:solidFill>
+                <a:latin typeface="Calibri"/>
+              </a:rPr>
+              <a:t>On the slotted antenna the forests predict S11, gain and radiation efficiency from the 10 dimensions and frequency.</a:t>
+            </a:r>
+          </a:p>
+          <a:p>
+            <a:pPr algn="l">
               <a:spcBef>
                 <a:spcPts val="500"/>
               </a:spcBef>
@@ -10193,27 +10184,11 @@
                 </a:solidFill>
                 <a:latin typeface="Calibri"/>
               </a:rPr>
-              <a:t>On the slotted antenna the forests predict S11, gain and radiation efficiency from the 10 dimensions and frequency.</a:t>
-            </a:r>
-          </a:p>
-          <a:p>
-            <a:pPr>
-              <a:spcBef>
-                <a:spcPts val="500"/>
-              </a:spcBef>
-            </a:pPr>
-            <a:r>
-              <a:rPr sz="1300">
-                <a:solidFill>
-                  <a:srgbClr val="0B2A4A"/>
-                </a:solidFill>
-                <a:latin typeface="Calibri"/>
-              </a:rPr>
               <a:t>Adding the slot and substrate dimensions roughly halves the error of a frequency-only model - the geometry matters.</a:t>
             </a:r>
           </a:p>
           <a:p>
-            <a:pPr>
+            <a:pPr algn="l">
               <a:spcBef>
                 <a:spcPts val="500"/>
               </a:spcBef>
@@ -11027,14 +11002,14 @@
       </p:sp>
       <p:sp>
         <p:nvSpPr>
-          <p:cNvPr id="17" name="Note bubble"/>
+          <p:cNvPr id="17" name="Explanation bubble"/>
           <p:cNvSpPr/>
           <p:nvPr/>
         </p:nvSpPr>
         <p:spPr>
           <a:xfrm>
             <a:off x="8641080" y="1417320"/>
-            <a:ext cx="3017520" cy="3483864"/>
+            <a:ext cx="3017520" cy="3259836"/>
           </a:xfrm>
           <a:prstGeom prst="wedgeRoundRectCallout">
             <a:avLst>
@@ -11071,19 +11046,23 @@
           <a:bodyPr rtlCol="0" anchor="t" wrap="square" lIns="164592" rIns="164592" tIns="128016"/>
           <a:lstStyle/>
           <a:p>
-            <a:pPr algn="ctr"/>
-            <a:r>
-              <a:rPr sz="1400" b="1">
-                <a:solidFill>
-                  <a:srgbClr val="8A5A00"/>
-                </a:solidFill>
-                <a:latin typeface="Calibri"/>
-              </a:rPr>
-              <a:t>Note</a:t>
-            </a:r>
-          </a:p>
-          <a:p>
-            <a:pPr>
+            <a:pPr algn="l">
+              <a:spcBef>
+                <a:spcPts val="0"/>
+              </a:spcBef>
+            </a:pPr>
+            <a:r>
+              <a:rPr sz="1300">
+                <a:solidFill>
+                  <a:srgbClr val="0B2A4A"/>
+                </a:solidFill>
+                <a:latin typeface="Calibri"/>
+              </a:rPr>
+              <a:t>Engineers read sentences faster than tables, so each prediction is also written as a short summary.</a:t>
+            </a:r>
+          </a:p>
+          <a:p>
+            <a:pPr algn="l">
               <a:spcBef>
                 <a:spcPts val="500"/>
               </a:spcBef>
@@ -11095,27 +11074,11 @@
                 </a:solidFill>
                 <a:latin typeface="Calibri"/>
               </a:rPr>
-              <a:t>Engineers read sentences faster than tables, so each prediction is also written as a short summary.</a:t>
-            </a:r>
-          </a:p>
-          <a:p>
-            <a:pPr>
-              <a:spcBef>
-                <a:spcPts val="500"/>
-              </a:spcBef>
-            </a:pPr>
-            <a:r>
-              <a:rPr sz="1300">
-                <a:solidFill>
-                  <a:srgbClr val="0B2A4A"/>
-                </a:solidFill>
-                <a:latin typeface="Calibri"/>
-              </a:rPr>
               <a:t>This is data-to-text generation with rules and templates - deliberately not a large language model, which could invent values.</a:t>
             </a:r>
           </a:p>
           <a:p>
-            <a:pPr>
+            <a:pPr algn="l">
               <a:spcBef>
                 <a:spcPts val="500"/>
               </a:spcBef>
@@ -11821,14 +11784,14 @@
       </p:pic>
       <p:sp>
         <p:nvSpPr>
-          <p:cNvPr id="8" name="Note bubble"/>
+          <p:cNvPr id="8" name="Explanation bubble"/>
           <p:cNvSpPr/>
           <p:nvPr/>
         </p:nvSpPr>
         <p:spPr>
           <a:xfrm>
             <a:off x="8641080" y="1417320"/>
-            <a:ext cx="3017520" cy="3931919"/>
+            <a:ext cx="3017520" cy="3707891"/>
           </a:xfrm>
           <a:prstGeom prst="wedgeRoundRectCallout">
             <a:avLst>
@@ -11865,19 +11828,23 @@
           <a:bodyPr rtlCol="0" anchor="t" wrap="square" lIns="164592" rIns="164592" tIns="128016"/>
           <a:lstStyle/>
           <a:p>
-            <a:pPr algn="ctr"/>
-            <a:r>
-              <a:rPr sz="1400" b="1">
-                <a:solidFill>
-                  <a:srgbClr val="8A5A00"/>
-                </a:solidFill>
-                <a:latin typeface="Calibri"/>
-              </a:rPr>
-              <a:t>Note</a:t>
-            </a:r>
-          </a:p>
-          <a:p>
-            <a:pPr>
+            <a:pPr algn="l">
+              <a:spcBef>
+                <a:spcPts val="0"/>
+              </a:spcBef>
+            </a:pPr>
+            <a:r>
+              <a:rPr sz="1300">
+                <a:solidFill>
+                  <a:srgbClr val="0B2A4A"/>
+                </a:solidFill>
+                <a:latin typeface="Calibri"/>
+              </a:rPr>
+              <a:t>Task: predict the matching class (Poor / Acceptable / High). Fusion scored 0.737, below the image embedding alone (0.775), so the pre-registered hypothesis H6 is not supported.</a:t>
+            </a:r>
+          </a:p>
+          <a:p>
+            <a:pPr algn="l">
               <a:spcBef>
                 <a:spcPts val="500"/>
               </a:spcBef>
@@ -11889,27 +11856,11 @@
                 </a:solidFill>
                 <a:latin typeface="Calibri"/>
               </a:rPr>
-              <a:t>Task: predict the matching class (Poor / Acceptable / High). Fusion scored 0.737, below the image embedding alone (0.775), so the pre-registered hypothesis H6 is not supported.</a:t>
-            </a:r>
-          </a:p>
-          <a:p>
-            <a:pPr>
-              <a:spcBef>
-                <a:spcPts val="500"/>
-              </a:spcBef>
-            </a:pPr>
-            <a:r>
-              <a:rPr sz="1300">
-                <a:solidFill>
-                  <a:srgbClr val="0B2A4A"/>
-                </a:solidFill>
-                <a:latin typeface="Calibri"/>
-              </a:rPr>
               <a:t>The image-only MLP beats Module 1's own ViT head (0.581): the ViT features are better than its classifier suggested.</a:t>
             </a:r>
           </a:p>
           <a:p>
-            <a:pPr>
+            <a:pPr algn="l">
               <a:spcBef>
                 <a:spcPts val="500"/>
               </a:spcBef>
@@ -12733,14 +12684,14 @@
       </p:graphicFrame>
       <p:sp>
         <p:nvSpPr>
-          <p:cNvPr id="11" name="Note bubble"/>
+          <p:cNvPr id="11" name="Explanation bubble"/>
           <p:cNvSpPr/>
           <p:nvPr/>
         </p:nvSpPr>
         <p:spPr>
           <a:xfrm>
             <a:off x="8641080" y="1417320"/>
-            <a:ext cx="3017520" cy="3566160"/>
+            <a:ext cx="3017520" cy="3342132"/>
           </a:xfrm>
           <a:prstGeom prst="wedgeRoundRectCallout">
             <a:avLst>
@@ -12777,19 +12728,23 @@
           <a:bodyPr rtlCol="0" anchor="t" wrap="square" lIns="164592" rIns="164592" tIns="128016"/>
           <a:lstStyle/>
           <a:p>
-            <a:pPr algn="ctr"/>
-            <a:r>
-              <a:rPr sz="1400" b="1">
-                <a:solidFill>
-                  <a:srgbClr val="8A5A00"/>
-                </a:solidFill>
-                <a:latin typeface="Calibri"/>
-              </a:rPr>
-              <a:t>Note</a:t>
-            </a:r>
-          </a:p>
-          <a:p>
-            <a:pPr>
+            <a:pPr algn="l">
+              <a:spcBef>
+                <a:spcPts val="0"/>
+              </a:spcBef>
+            </a:pPr>
+            <a:r>
+              <a:rPr sz="1300">
+                <a:solidFill>
+                  <a:srgbClr val="0B2A4A"/>
+                </a:solidFill>
+                <a:latin typeface="Calibri"/>
+              </a:rPr>
+              <a:t>NSGA-II found 100 trade-off designs, from 299 to 2754 mm².</a:t>
+            </a:r>
+          </a:p>
+          <a:p>
+            <a:pPr algn="l">
               <a:spcBef>
                 <a:spcPts val="500"/>
               </a:spcBef>
@@ -12801,11 +12756,11 @@
                 </a:solidFill>
                 <a:latin typeface="Calibri"/>
               </a:rPr>
-              <a:t>NSGA-II found 100 trade-off designs, from 299 to 2754 mm².</a:t>
-            </a:r>
-          </a:p>
-          <a:p>
-            <a:pPr>
+              <a:t>Each dot is a compromise: smaller area costs bandwidth or match depth.</a:t>
+            </a:r>
+          </a:p>
+          <a:p>
+            <a:pPr algn="l">
               <a:spcBef>
                 <a:spcPts val="500"/>
               </a:spcBef>
@@ -12817,27 +12772,11 @@
                 </a:solidFill>
                 <a:latin typeface="Calibri"/>
               </a:rPr>
-              <a:t>Each dot is a compromise: smaller area costs bandwidth or match depth.</a:t>
-            </a:r>
-          </a:p>
-          <a:p>
-            <a:pPr>
-              <a:spcBef>
-                <a:spcPts val="500"/>
-              </a:spcBef>
-            </a:pPr>
-            <a:r>
-              <a:rPr sz="1300">
-                <a:solidFill>
-                  <a:srgbClr val="0B2A4A"/>
-                </a:solidFill>
-                <a:latin typeface="Calibri"/>
-              </a:rPr>
               <a:t>All proposals sit close to simulated designs (median 0.08 SD) - interpolations, not miracles.</a:t>
             </a:r>
           </a:p>
           <a:p>
-            <a:pPr>
+            <a:pPr algn="l">
               <a:spcBef>
                 <a:spcPts val="500"/>
               </a:spcBef>
@@ -13546,14 +13485,14 @@
       </p:graphicFrame>
       <p:sp>
         <p:nvSpPr>
-          <p:cNvPr id="7" name="Note bubble"/>
+          <p:cNvPr id="7" name="Explanation bubble"/>
           <p:cNvSpPr/>
           <p:nvPr/>
         </p:nvSpPr>
         <p:spPr>
           <a:xfrm>
             <a:off x="8641080" y="1417320"/>
-            <a:ext cx="3017520" cy="4014215"/>
+            <a:ext cx="3017520" cy="3790188"/>
           </a:xfrm>
           <a:prstGeom prst="wedgeRoundRectCallout">
             <a:avLst>
@@ -13590,19 +13529,23 @@
           <a:bodyPr rtlCol="0" anchor="t" wrap="square" lIns="164592" rIns="164592" tIns="128016"/>
           <a:lstStyle/>
           <a:p>
-            <a:pPr algn="ctr"/>
-            <a:r>
-              <a:rPr sz="1400" b="1">
-                <a:solidFill>
-                  <a:srgbClr val="8A5A00"/>
-                </a:solidFill>
-                <a:latin typeface="Calibri"/>
-              </a:rPr>
-              <a:t>Note</a:t>
-            </a:r>
-          </a:p>
-          <a:p>
-            <a:pPr>
+            <a:pPr algn="l">
+              <a:spcBef>
+                <a:spcPts val="0"/>
+              </a:spcBef>
+            </a:pPr>
+            <a:r>
+              <a:rPr sz="1300">
+                <a:solidFill>
+                  <a:srgbClr val="0B2A4A"/>
+                </a:solidFill>
+                <a:latin typeface="Calibri"/>
+              </a:rPr>
+              <a:t>AI changes where the engineer spends time: less waiting for sweeps, more judging a ranked shortlist.</a:t>
+            </a:r>
+          </a:p>
+          <a:p>
+            <a:pPr algn="l">
               <a:spcBef>
                 <a:spcPts val="500"/>
               </a:spcBef>
@@ -13614,11 +13557,11 @@
                 </a:solidFill>
                 <a:latin typeface="Calibri"/>
               </a:rPr>
-              <a:t>AI changes where the engineer spends time: less waiting for sweeps, more judging a ranked shortlist.</a:t>
-            </a:r>
-          </a:p>
-          <a:p>
-            <a:pPr>
+              <a:t>It complements, not replaces, HFSS - every promising design is still simulated and measured.</a:t>
+            </a:r>
+          </a:p>
+          <a:p>
+            <a:pPr algn="l">
               <a:spcBef>
                 <a:spcPts val="500"/>
               </a:spcBef>
@@ -13630,27 +13573,11 @@
                 </a:solidFill>
                 <a:latin typeface="Calibri"/>
               </a:rPr>
-              <a:t>It complements, not replaces, HFSS - every promising design is still simulated and measured.</a:t>
-            </a:r>
-          </a:p>
-          <a:p>
-            <a:pPr>
-              <a:spcBef>
-                <a:spcPts val="500"/>
-              </a:spcBef>
-            </a:pPr>
-            <a:r>
-              <a:rPr sz="1300">
-                <a:solidFill>
-                  <a:srgbClr val="0B2A4A"/>
-                </a:solidFill>
-                <a:latin typeface="Calibri"/>
-              </a:rPr>
               <a:t>The out-of-distribution test shows engineers exactly when not to trust the surrogate.</a:t>
             </a:r>
           </a:p>
           <a:p>
-            <a:pPr>
+            <a:pPr algn="l">
               <a:spcBef>
                 <a:spcPts val="500"/>
               </a:spcBef>
@@ -14340,14 +14267,14 @@
       </p:sp>
       <p:sp>
         <p:nvSpPr>
-          <p:cNvPr id="8" name="Note bubble"/>
+          <p:cNvPr id="8" name="Explanation bubble"/>
           <p:cNvSpPr/>
           <p:nvPr/>
         </p:nvSpPr>
         <p:spPr>
           <a:xfrm>
             <a:off x="8641080" y="1417320"/>
-            <a:ext cx="3017520" cy="3035808"/>
+            <a:ext cx="3017520" cy="2811780"/>
           </a:xfrm>
           <a:prstGeom prst="wedgeRoundRectCallout">
             <a:avLst>
@@ -14384,19 +14311,23 @@
           <a:bodyPr rtlCol="0" anchor="t" wrap="square" lIns="164592" rIns="164592" tIns="128016"/>
           <a:lstStyle/>
           <a:p>
-            <a:pPr algn="ctr"/>
-            <a:r>
-              <a:rPr sz="1400" b="1">
-                <a:solidFill>
-                  <a:srgbClr val="8A5A00"/>
-                </a:solidFill>
-                <a:latin typeface="Calibri"/>
-              </a:rPr>
-              <a:t>Note</a:t>
-            </a:r>
-          </a:p>
-          <a:p>
-            <a:pPr>
+            <a:pPr algn="l">
+              <a:spcBef>
+                <a:spcPts val="0"/>
+              </a:spcBef>
+            </a:pPr>
+            <a:r>
+              <a:rPr sz="1300">
+                <a:solidFill>
+                  <a:srgbClr val="0B2A4A"/>
+                </a:solidFill>
+                <a:latin typeface="Calibri"/>
+              </a:rPr>
+              <a:t>E1-E3 are the planned evaluation criteria; H6 was pre-registered before any fusion result existed.</a:t>
+            </a:r>
+          </a:p>
+          <a:p>
+            <a:pPr algn="l">
               <a:spcBef>
                 <a:spcPts val="500"/>
               </a:spcBef>
@@ -14408,27 +14339,11 @@
                 </a:solidFill>
                 <a:latin typeface="Calibri"/>
               </a:rPr>
-              <a:t>E1-E3 are the planned evaluation criteria; H6 was pre-registered before any fusion result existed.</a:t>
-            </a:r>
-          </a:p>
-          <a:p>
-            <a:pPr>
-              <a:spcBef>
-                <a:spcPts val="500"/>
-              </a:spcBef>
-            </a:pPr>
-            <a:r>
-              <a:rPr sz="1300">
-                <a:solidFill>
-                  <a:srgbClr val="0B2A4A"/>
-                </a:solidFill>
-                <a:latin typeface="Calibri"/>
-              </a:rPr>
               <a:t>Three criteria met, one hypothesis not supported - reported as found, not adjusted.</a:t>
             </a:r>
           </a:p>
           <a:p>
-            <a:pPr>
+            <a:pPr algn="l">
               <a:spcBef>
                 <a:spcPts val="500"/>
               </a:spcBef>
@@ -15603,14 +15518,14 @@
       </p:sp>
       <p:sp>
         <p:nvSpPr>
-          <p:cNvPr id="30" name="Note bubble"/>
+          <p:cNvPr id="30" name="Explanation bubble"/>
           <p:cNvSpPr/>
           <p:nvPr/>
         </p:nvSpPr>
         <p:spPr>
           <a:xfrm>
             <a:off x="8641080" y="1417320"/>
-            <a:ext cx="3017520" cy="3035808"/>
+            <a:ext cx="3017520" cy="2363724"/>
           </a:xfrm>
           <a:prstGeom prst="wedgeRoundRectCallout">
             <a:avLst>
@@ -15647,19 +15562,23 @@
           <a:bodyPr rtlCol="0" anchor="t" wrap="square" lIns="164592" rIns="164592" tIns="128016"/>
           <a:lstStyle/>
           <a:p>
-            <a:pPr algn="ctr"/>
-            <a:r>
-              <a:rPr sz="1400" b="1">
-                <a:solidFill>
-                  <a:srgbClr val="8A5A00"/>
-                </a:solidFill>
-                <a:latin typeface="Calibri"/>
-              </a:rPr>
-              <a:t>Note</a:t>
-            </a:r>
-          </a:p>
-          <a:p>
-            <a:pPr>
+            <a:pPr algn="l">
+              <a:spcBef>
+                <a:spcPts val="0"/>
+              </a:spcBef>
+            </a:pPr>
+            <a:r>
+              <a:rPr sz="1300">
+                <a:solidFill>
+                  <a:srgbClr val="0B2A4A"/>
+                </a:solidFill>
+                <a:latin typeface="Calibri"/>
+              </a:rPr>
+              <a:t>The deck moves from physics to data to AI to engineering value.</a:t>
+            </a:r>
+          </a:p>
+          <a:p>
+            <a:pPr algn="l">
               <a:spcBef>
                 <a:spcPts val="500"/>
               </a:spcBef>
@@ -15671,27 +15590,11 @@
                 </a:solidFill>
                 <a:latin typeface="Calibri"/>
               </a:rPr>
-              <a:t>The deck moves from physics to data to AI to engineering value.</a:t>
-            </a:r>
-          </a:p>
-          <a:p>
-            <a:pPr>
-              <a:spcBef>
-                <a:spcPts val="500"/>
-              </a:spcBef>
-            </a:pPr>
-            <a:r>
-              <a:rPr sz="1300">
-                <a:solidFill>
-                  <a:srgbClr val="0B2A4A"/>
-                </a:solidFill>
-                <a:latin typeface="Calibri"/>
-              </a:rPr>
-              <a:t>Yellow bubbles like this one carry the presenter's explanation for each slide; the same text is in the speaker notes.</a:t>
-            </a:r>
-          </a:p>
-          <a:p>
-            <a:pPr>
+              <a:t>Yellow bubbles like this one explain each slide in plain words.</a:t>
+            </a:r>
+          </a:p>
+          <a:p>
+            <a:pPr algn="l">
               <a:spcBef>
                 <a:spcPts val="500"/>
               </a:spcBef>
@@ -16613,7 +16516,7 @@
                 </a:solidFill>
                 <a:latin typeface="Calibri"/>
               </a:rPr>
-              <a:t>10 passed in 2.71s</a:t>
+              <a:t>10 passed in 1.30s</a:t>
             </a:r>
           </a:p>
         </p:txBody>
@@ -17084,14 +16987,14 @@
       </p:sp>
       <p:sp>
         <p:nvSpPr>
-          <p:cNvPr id="7" name="Note bubble"/>
+          <p:cNvPr id="7" name="Explanation bubble"/>
           <p:cNvSpPr/>
           <p:nvPr/>
         </p:nvSpPr>
         <p:spPr>
           <a:xfrm>
             <a:off x="8641080" y="1417320"/>
-            <a:ext cx="3017520" cy="2811780"/>
+            <a:ext cx="3017520" cy="2587752"/>
           </a:xfrm>
           <a:prstGeom prst="wedgeRoundRectCallout">
             <a:avLst>
@@ -17128,19 +17031,23 @@
           <a:bodyPr rtlCol="0" anchor="t" wrap="square" lIns="164592" rIns="164592" tIns="128016"/>
           <a:lstStyle/>
           <a:p>
-            <a:pPr algn="ctr"/>
-            <a:r>
-              <a:rPr sz="1400" b="1">
-                <a:solidFill>
-                  <a:srgbClr val="8A5A00"/>
-                </a:solidFill>
-                <a:latin typeface="Calibri"/>
-              </a:rPr>
-              <a:t>Note</a:t>
-            </a:r>
-          </a:p>
-          <a:p>
-            <a:pPr>
+            <a:pPr algn="l">
+              <a:spcBef>
+                <a:spcPts val="0"/>
+              </a:spcBef>
+            </a:pPr>
+            <a:r>
+              <a:rPr sz="1300">
+                <a:solidFill>
+                  <a:srgbClr val="0B2A4A"/>
+                </a:solidFill>
+                <a:latin typeface="Calibri"/>
+              </a:rPr>
+              <a:t>Datasets are cited with their licences, as their terms require.</a:t>
+            </a:r>
+          </a:p>
+          <a:p>
+            <a:pPr algn="l">
               <a:spcBef>
                 <a:spcPts val="500"/>
               </a:spcBef>
@@ -17152,27 +17059,11 @@
                 </a:solidFill>
                 <a:latin typeface="Calibri"/>
               </a:rPr>
-              <a:t>Datasets are cited with their licences, as their terms require.</a:t>
-            </a:r>
-          </a:p>
-          <a:p>
-            <a:pPr>
-              <a:spcBef>
-                <a:spcPts val="500"/>
-              </a:spcBef>
-            </a:pPr>
-            <a:r>
-              <a:rPr sz="1300">
-                <a:solidFill>
-                  <a:srgbClr val="0B2A4A"/>
-                </a:solidFill>
-                <a:latin typeface="Calibri"/>
-              </a:rPr>
               <a:t>Reiter &amp; Dale describe the data-to-text pipeline (content selection, realisation) used for the summaries.</a:t>
             </a:r>
           </a:p>
           <a:p>
-            <a:pPr>
+            <a:pPr algn="l">
               <a:spcBef>
                 <a:spcPts val="500"/>
               </a:spcBef>
@@ -17999,14 +17890,14 @@
       </p:graphicFrame>
       <p:sp>
         <p:nvSpPr>
-          <p:cNvPr id="10" name="Note bubble"/>
+          <p:cNvPr id="10" name="Explanation bubble"/>
           <p:cNvSpPr/>
           <p:nvPr/>
         </p:nvSpPr>
         <p:spPr>
           <a:xfrm>
             <a:off x="8641080" y="1417320"/>
-            <a:ext cx="3017520" cy="3483864"/>
+            <a:ext cx="3017520" cy="3259836"/>
           </a:xfrm>
           <a:prstGeom prst="wedgeRoundRectCallout">
             <a:avLst>
@@ -18043,19 +17934,23 @@
           <a:bodyPr rtlCol="0" anchor="t" wrap="square" lIns="164592" rIns="164592" tIns="128016"/>
           <a:lstStyle/>
           <a:p>
-            <a:pPr algn="ctr"/>
-            <a:r>
-              <a:rPr sz="1400" b="1">
-                <a:solidFill>
-                  <a:srgbClr val="8A5A00"/>
-                </a:solidFill>
-                <a:latin typeface="Calibri"/>
-              </a:rPr>
-              <a:t>Note</a:t>
-            </a:r>
-          </a:p>
-          <a:p>
-            <a:pPr>
+            <a:pPr algn="l">
+              <a:spcBef>
+                <a:spcPts val="0"/>
+              </a:spcBef>
+            </a:pPr>
+            <a:r>
+              <a:rPr sz="1300">
+                <a:solidFill>
+                  <a:srgbClr val="0B2A4A"/>
+                </a:solidFill>
+                <a:latin typeface="Calibri"/>
+              </a:rPr>
+              <a:t>Engineers judge an antenna by where it resonates, how well it is matched (S11), how wide its usable band is, and how much power it radiates (gain, efficiency).</a:t>
+            </a:r>
+          </a:p>
+          <a:p>
+            <a:pPr algn="l">
               <a:spcBef>
                 <a:spcPts val="500"/>
               </a:spcBef>
@@ -18067,27 +17962,11 @@
                 </a:solidFill>
                 <a:latin typeface="Calibri"/>
               </a:rPr>
-              <a:t>Engineers judge an antenna by where it resonates, how well it is matched (S11), how wide its usable band is, and how much power it radiates (gain, efficiency).</a:t>
-            </a:r>
-          </a:p>
-          <a:p>
-            <a:pPr>
-              <a:spcBef>
-                <a:spcPts val="500"/>
-              </a:spcBef>
-            </a:pPr>
-            <a:r>
-              <a:rPr sz="1300">
-                <a:solidFill>
-                  <a:srgbClr val="0B2A4A"/>
-                </a:solidFill>
-                <a:latin typeface="Calibri"/>
-              </a:rPr>
               <a:t>These same quantities are what Module 2's AI learns to predict from the design dimensions.</a:t>
             </a:r>
           </a:p>
           <a:p>
-            <a:pPr>
+            <a:pPr algn="l">
               <a:spcBef>
                 <a:spcPts val="500"/>
               </a:spcBef>
@@ -18650,14 +18529,14 @@
       </p:sp>
       <p:sp>
         <p:nvSpPr>
-          <p:cNvPr id="16" name="Note bubble"/>
+          <p:cNvPr id="16" name="Explanation bubble"/>
           <p:cNvSpPr/>
           <p:nvPr/>
         </p:nvSpPr>
         <p:spPr>
           <a:xfrm>
             <a:off x="8641080" y="1417320"/>
-            <a:ext cx="3017520" cy="4238244"/>
+            <a:ext cx="3017520" cy="4014215"/>
           </a:xfrm>
           <a:prstGeom prst="wedgeRoundRectCallout">
             <a:avLst>
@@ -18694,19 +18573,23 @@
           <a:bodyPr rtlCol="0" anchor="t" wrap="square" lIns="164592" rIns="164592" tIns="128016"/>
           <a:lstStyle/>
           <a:p>
-            <a:pPr algn="ctr"/>
-            <a:r>
-              <a:rPr sz="1400" b="1">
-                <a:solidFill>
-                  <a:srgbClr val="8A5A00"/>
-                </a:solidFill>
-                <a:latin typeface="Calibri"/>
-              </a:rPr>
-              <a:t>Note</a:t>
-            </a:r>
-          </a:p>
-          <a:p>
-            <a:pPr>
+            <a:pPr algn="l">
+              <a:spcBef>
+                <a:spcPts val="0"/>
+              </a:spcBef>
+            </a:pPr>
+            <a:r>
+              <a:rPr sz="1300">
+                <a:solidFill>
+                  <a:srgbClr val="0B2A4A"/>
+                </a:solidFill>
+                <a:latin typeface="Calibri"/>
+              </a:rPr>
+              <a:t>A plain patch has three main dimensions; a hybrid-slotted DGS antenna has dozens (slot lengths, widths, offsets, DGS shape).</a:t>
+            </a:r>
+          </a:p>
+          <a:p>
+            <a:pPr algn="l">
               <a:spcBef>
                 <a:spcPts val="500"/>
               </a:spcBef>
@@ -18718,11 +18601,11 @@
                 </a:solidFill>
                 <a:latin typeface="Calibri"/>
               </a:rPr>
-              <a:t>A plain patch has three main dimensions; a hybrid-slotted DGS antenna has dozens (slot lengths, widths, offsets, DGS shape).</a:t>
-            </a:r>
-          </a:p>
-          <a:p>
-            <a:pPr>
+              <a:t>Every extra dimension multiplies the number of full-wave simulations needed to explore the design.</a:t>
+            </a:r>
+          </a:p>
+          <a:p>
+            <a:pPr algn="l">
               <a:spcBef>
                 <a:spcPts val="500"/>
               </a:spcBef>
@@ -18734,27 +18617,11 @@
                 </a:solidFill>
                 <a:latin typeface="Calibri"/>
               </a:rPr>
-              <a:t>Every extra dimension multiplies the number of full-wave simulations needed to explore the design.</a:t>
-            </a:r>
-          </a:p>
-          <a:p>
-            <a:pPr>
-              <a:spcBef>
-                <a:spcPts val="500"/>
-              </a:spcBef>
-            </a:pPr>
-            <a:r>
-              <a:rPr sz="1300">
-                <a:solidFill>
-                  <a:srgbClr val="0B2A4A"/>
-                </a:solidFill>
-                <a:latin typeface="Calibri"/>
-              </a:rPr>
               <a:t>That combinatorial growth is exactly where a fast AI surrogate earns its place.</a:t>
             </a:r>
           </a:p>
           <a:p>
-            <a:pPr>
+            <a:pPr algn="l">
               <a:spcBef>
                 <a:spcPts val="500"/>
               </a:spcBef>
@@ -20188,14 +20055,14 @@
       </p:sp>
       <p:sp>
         <p:nvSpPr>
-          <p:cNvPr id="38" name="Note bubble"/>
+          <p:cNvPr id="38" name="Explanation bubble"/>
           <p:cNvSpPr/>
           <p:nvPr/>
         </p:nvSpPr>
         <p:spPr>
           <a:xfrm>
             <a:off x="8641080" y="1417320"/>
-            <a:ext cx="3017520" cy="4014215"/>
+            <a:ext cx="3017520" cy="3790188"/>
           </a:xfrm>
           <a:prstGeom prst="wedgeRoundRectCallout">
             <a:avLst>
@@ -20232,19 +20099,23 @@
           <a:bodyPr rtlCol="0" anchor="t" wrap="square" lIns="164592" rIns="164592" tIns="128016"/>
           <a:lstStyle/>
           <a:p>
-            <a:pPr algn="ctr"/>
-            <a:r>
-              <a:rPr sz="1400" b="1">
-                <a:solidFill>
-                  <a:srgbClr val="8A5A00"/>
-                </a:solidFill>
-                <a:latin typeface="Calibri"/>
-              </a:rPr>
-              <a:t>Note</a:t>
-            </a:r>
-          </a:p>
-          <a:p>
-            <a:pPr>
+            <a:pPr algn="l">
+              <a:spcBef>
+                <a:spcPts val="0"/>
+              </a:spcBef>
+            </a:pPr>
+            <a:r>
+              <a:rPr sz="1300">
+                <a:solidFill>
+                  <a:srgbClr val="0B2A4A"/>
+                </a:solidFill>
+                <a:latin typeface="Calibri"/>
+              </a:rPr>
+              <a:t>The AI does not replace the solver: it learns from solver results, then screens new candidates almost instantly.</a:t>
+            </a:r>
+          </a:p>
+          <a:p>
+            <a:pPr algn="l">
               <a:spcBef>
                 <a:spcPts val="500"/>
               </a:spcBef>
@@ -20256,11 +20127,11 @@
                 </a:solidFill>
                 <a:latin typeface="Calibri"/>
               </a:rPr>
-              <a:t>The AI does not replace the solver: it learns from solver results, then screens new candidates almost instantly.</a:t>
-            </a:r>
-          </a:p>
-          <a:p>
-            <a:pPr>
+              <a:t>Speeds on this slide were measured on the project laptop (src/timing.py).</a:t>
+            </a:r>
+          </a:p>
+          <a:p>
+            <a:pPr algn="l">
               <a:spcBef>
                 <a:spcPts val="500"/>
               </a:spcBef>
@@ -20272,27 +20143,11 @@
                 </a:solidFill>
                 <a:latin typeface="Calibri"/>
               </a:rPr>
-              <a:t>Speeds on this slide were measured on the project laptop (src/timing.py).</a:t>
-            </a:r>
-          </a:p>
-          <a:p>
-            <a:pPr>
-              <a:spcBef>
-                <a:spcPts val="500"/>
-              </a:spcBef>
-            </a:pPr>
-            <a:r>
-              <a:rPr sz="1300">
-                <a:solidFill>
-                  <a:srgbClr val="0B2A4A"/>
-                </a:solidFill>
-                <a:latin typeface="Calibri"/>
-              </a:rPr>
               <a:t>Only the short-listed designs go back to full-wave simulation, so fewer expensive runs are needed.</a:t>
             </a:r>
           </a:p>
           <a:p>
-            <a:pPr>
+            <a:pPr algn="l">
               <a:spcBef>
                 <a:spcPts val="500"/>
               </a:spcBef>
@@ -21412,14 +21267,14 @@
       </p:graphicFrame>
       <p:sp>
         <p:nvSpPr>
-          <p:cNvPr id="21" name="Note bubble"/>
+          <p:cNvPr id="21" name="Explanation bubble"/>
           <p:cNvSpPr/>
           <p:nvPr/>
         </p:nvSpPr>
         <p:spPr>
           <a:xfrm>
             <a:off x="8641080" y="1417320"/>
-            <a:ext cx="3017520" cy="4014215"/>
+            <a:ext cx="3017520" cy="3790188"/>
           </a:xfrm>
           <a:prstGeom prst="wedgeRoundRectCallout">
             <a:avLst>
@@ -21456,19 +21311,23 @@
           <a:bodyPr rtlCol="0" anchor="t" wrap="square" lIns="164592" rIns="164592" tIns="128016"/>
           <a:lstStyle/>
           <a:p>
-            <a:pPr algn="ctr"/>
-            <a:r>
-              <a:rPr sz="1400" b="1">
-                <a:solidFill>
-                  <a:srgbClr val="8A5A00"/>
-                </a:solidFill>
-                <a:latin typeface="Calibri"/>
-              </a:rPr>
-              <a:t>Note</a:t>
-            </a:r>
-          </a:p>
-          <a:p>
-            <a:pPr>
+            <a:pPr algn="l">
+              <a:spcBef>
+                <a:spcPts val="0"/>
+              </a:spcBef>
+            </a:pPr>
+            <a:r>
+              <a:rPr sz="1300">
+                <a:solidFill>
+                  <a:srgbClr val="0B2A4A"/>
+                </a:solidFill>
+                <a:latin typeface="Calibri"/>
+              </a:rPr>
+              <a:t>The work is a fixed sequence of stages, each a script in the repository, so anyone can rerun it end to end.</a:t>
+            </a:r>
+          </a:p>
+          <a:p>
+            <a:pPr algn="l">
               <a:spcBef>
                 <a:spcPts val="500"/>
               </a:spcBef>
@@ -21480,11 +21339,11 @@
                 </a:solidFill>
                 <a:latin typeface="Calibri"/>
               </a:rPr>
-              <a:t>The work is a fixed sequence of stages, each a script in the repository, so anyone can rerun it end to end.</a:t>
-            </a:r>
-          </a:p>
-          <a:p>
-            <a:pPr>
+              <a:t>Stages 1-5 are classic supervised machine learning on tabular data.</a:t>
+            </a:r>
+          </a:p>
+          <a:p>
+            <a:pPr algn="l">
               <a:spcBef>
                 <a:spcPts val="500"/>
               </a:spcBef>
@@ -21496,27 +21355,11 @@
                 </a:solidFill>
                 <a:latin typeface="Calibri"/>
               </a:rPr>
-              <a:t>Stages 1-5 are classic supervised machine learning on tabular data.</a:t>
-            </a:r>
-          </a:p>
-          <a:p>
-            <a:pPr>
-              <a:spcBef>
-                <a:spcPts val="500"/>
-              </a:spcBef>
-            </a:pPr>
-            <a:r>
-              <a:rPr sz="1300">
-                <a:solidFill>
-                  <a:srgbClr val="0B2A4A"/>
-                </a:solidFill>
-                <a:latin typeface="Calibri"/>
-              </a:rPr>
               <a:t>Stage 6 is where text enters: the AI's numbers are turned into readable engineering sentences.</a:t>
             </a:r>
           </a:p>
           <a:p>
-            <a:pPr>
+            <a:pPr algn="l">
               <a:spcBef>
                 <a:spcPts val="500"/>
               </a:spcBef>
@@ -22225,14 +22068,14 @@
       </p:graphicFrame>
       <p:sp>
         <p:nvSpPr>
-          <p:cNvPr id="7" name="Note bubble"/>
+          <p:cNvPr id="7" name="Explanation bubble"/>
           <p:cNvSpPr/>
           <p:nvPr/>
         </p:nvSpPr>
         <p:spPr>
           <a:xfrm>
             <a:off x="8641080" y="1417320"/>
-            <a:ext cx="3017520" cy="4238244"/>
+            <a:ext cx="3017520" cy="4014215"/>
           </a:xfrm>
           <a:prstGeom prst="wedgeRoundRectCallout">
             <a:avLst>
@@ -22269,19 +22112,23 @@
           <a:bodyPr rtlCol="0" anchor="t" wrap="square" lIns="164592" rIns="164592" tIns="128016"/>
           <a:lstStyle/>
           <a:p>
-            <a:pPr algn="ctr"/>
-            <a:r>
-              <a:rPr sz="1400" b="1">
-                <a:solidFill>
-                  <a:srgbClr val="8A5A00"/>
-                </a:solidFill>
-                <a:latin typeface="Calibri"/>
-              </a:rPr>
-              <a:t>Note</a:t>
-            </a:r>
-          </a:p>
-          <a:p>
-            <a:pPr>
+            <a:pPr algn="l">
+              <a:spcBef>
+                <a:spcPts val="0"/>
+              </a:spcBef>
+            </a:pPr>
+            <a:r>
+              <a:rPr sz="1300">
+                <a:solidFill>
+                  <a:srgbClr val="0B2A4A"/>
+                </a:solidFill>
+                <a:latin typeface="Calibri"/>
+              </a:rPr>
+              <a:t>Module 2 is a numerical-text module: its inputs are numbers and its text is an output.</a:t>
+            </a:r>
+          </a:p>
+          <a:p>
+            <a:pPr algn="l">
               <a:spcBef>
                 <a:spcPts val="500"/>
               </a:spcBef>
@@ -22293,11 +22140,11 @@
                 </a:solidFill>
                 <a:latin typeface="Calibri"/>
               </a:rPr>
-              <a:t>Module 2 is a numerical-text module: its inputs are numbers and its text is an output.</a:t>
-            </a:r>
-          </a:p>
-          <a:p>
-            <a:pPr>
+              <a:t>So linguistic analysis of input text (tokenising, parsing, sentiment) is not used - there is no input text to analyse.</a:t>
+            </a:r>
+          </a:p>
+          <a:p>
+            <a:pPr algn="l">
               <a:spcBef>
                 <a:spcPts val="500"/>
               </a:spcBef>
@@ -22309,27 +22156,11 @@
                 </a:solidFill>
                 <a:latin typeface="Calibri"/>
               </a:rPr>
-              <a:t>So linguistic analysis of input text (tokenising, parsing, sentiment) is not used - there is no input text to analyse.</a:t>
-            </a:r>
-          </a:p>
-          <a:p>
-            <a:pPr>
-              <a:spcBef>
-                <a:spcPts val="500"/>
-              </a:spcBef>
-            </a:pPr>
-            <a:r>
-              <a:rPr sz="1300">
-                <a:solidFill>
-                  <a:srgbClr val="0B2A4A"/>
-                </a:solidFill>
-                <a:latin typeface="Calibri"/>
-              </a:rPr>
               <a:t>The 'semantic' step happens when writing: rules decide what a number means for an engineer (in n78? matched?).</a:t>
             </a:r>
           </a:p>
           <a:p>
-            <a:pPr>
+            <a:pPr algn="l">
               <a:spcBef>
                 <a:spcPts val="500"/>
               </a:spcBef>
@@ -22986,14 +22817,14 @@
       </p:sp>
       <p:sp>
         <p:nvSpPr>
-          <p:cNvPr id="18" name="Note bubble"/>
+          <p:cNvPr id="18" name="Explanation bubble"/>
           <p:cNvSpPr/>
           <p:nvPr/>
         </p:nvSpPr>
         <p:spPr>
           <a:xfrm>
             <a:off x="8641080" y="1417320"/>
-            <a:ext cx="3017520" cy="4014215"/>
+            <a:ext cx="3017520" cy="3790188"/>
           </a:xfrm>
           <a:prstGeom prst="wedgeRoundRectCallout">
             <a:avLst>
@@ -23030,19 +22861,23 @@
           <a:bodyPr rtlCol="0" anchor="t" wrap="square" lIns="164592" rIns="164592" tIns="128016"/>
           <a:lstStyle/>
           <a:p>
-            <a:pPr algn="ctr"/>
-            <a:r>
-              <a:rPr sz="1400" b="1">
-                <a:solidFill>
-                  <a:srgbClr val="8A5A00"/>
-                </a:solidFill>
-                <a:latin typeface="Calibri"/>
-              </a:rPr>
-              <a:t>Note</a:t>
-            </a:r>
-          </a:p>
-          <a:p>
-            <a:pPr>
+            <a:pPr algn="l">
+              <a:spcBef>
+                <a:spcPts val="0"/>
+              </a:spcBef>
+            </a:pPr>
+            <a:r>
+              <a:rPr sz="1300">
+                <a:solidFill>
+                  <a:srgbClr val="0B2A4A"/>
+                </a:solidFill>
+                <a:latin typeface="Calibri"/>
+              </a:rPr>
+              <a:t>No public HFSS dataset of hybrid-slotted DGS antennas exists, so two verified public simulation datasets stand in.</a:t>
+            </a:r>
+          </a:p>
+          <a:p>
+            <a:pPr algn="l">
               <a:spcBef>
                 <a:spcPts val="500"/>
               </a:spcBef>
@@ -23054,11 +22889,11 @@
                 </a:solidFill>
                 <a:latin typeface="Calibri"/>
               </a:rPr>
-              <a:t>No public HFSS dataset of hybrid-slotted DGS antennas exists, so two verified public simulation datasets stand in.</a:t>
-            </a:r>
-          </a:p>
-          <a:p>
-            <a:pPr>
+              <a:t>The patch sweep gives full S11 curves; the Mendeley set adds slots, gain and efficiency.</a:t>
+            </a:r>
+          </a:p>
+          <a:p>
+            <a:pPr algn="l">
               <a:spcBef>
                 <a:spcPts val="500"/>
               </a:spcBef>
@@ -23070,27 +22905,11 @@
                 </a:solidFill>
                 <a:latin typeface="Calibri"/>
               </a:rPr>
-              <a:t>The patch sweep gives full S11 curves; the Mendeley set adds slots, gain and efficiency.</a:t>
-            </a:r>
-          </a:p>
-          <a:p>
-            <a:pPr>
-              <a:spcBef>
-                <a:spcPts val="500"/>
-              </a:spcBef>
-            </a:pPr>
-            <a:r>
-              <a:rPr sz="1300">
-                <a:solidFill>
-                  <a:srgbClr val="0B2A4A"/>
-                </a:solidFill>
-                <a:latin typeface="Calibri"/>
-              </a:rPr>
               <a:t>Raw files are re-downloaded by script with checksums, so the data trail is reproducible.</a:t>
             </a:r>
           </a:p>
           <a:p>
-            <a:pPr>
+            <a:pPr algn="l">
               <a:spcBef>
                 <a:spcPts val="500"/>
               </a:spcBef>
@@ -23561,14 +23380,14 @@
       </p:sp>
       <p:sp>
         <p:nvSpPr>
-          <p:cNvPr id="9" name="Note bubble"/>
+          <p:cNvPr id="9" name="Explanation bubble"/>
           <p:cNvSpPr/>
           <p:nvPr/>
         </p:nvSpPr>
         <p:spPr>
           <a:xfrm>
             <a:off x="8641080" y="1417320"/>
-            <a:ext cx="3017520" cy="3483864"/>
+            <a:ext cx="3017520" cy="3259836"/>
           </a:xfrm>
           <a:prstGeom prst="wedgeRoundRectCallout">
             <a:avLst>
@@ -23605,19 +23424,23 @@
           <a:bodyPr rtlCol="0" anchor="t" wrap="square" lIns="164592" rIns="164592" tIns="128016"/>
           <a:lstStyle/>
           <a:p>
-            <a:pPr algn="ctr"/>
-            <a:r>
-              <a:rPr sz="1400" b="1">
-                <a:solidFill>
-                  <a:srgbClr val="8A5A00"/>
-                </a:solidFill>
-                <a:latin typeface="Calibri"/>
-              </a:rPr>
-              <a:t>Note</a:t>
-            </a:r>
-          </a:p>
-          <a:p>
-            <a:pPr>
+            <a:pPr algn="l">
+              <a:spcBef>
+                <a:spcPts val="0"/>
+              </a:spcBef>
+            </a:pPr>
+            <a:r>
+              <a:rPr sz="1300">
+                <a:solidFill>
+                  <a:srgbClr val="0B2A4A"/>
+                </a:solidFill>
+                <a:latin typeface="Calibri"/>
+              </a:rPr>
+              <a:t>For numeric data, 'noise removal' means finding values that cannot be physical and handling them by a fixed, documented rule.</a:t>
+            </a:r>
+          </a:p>
+          <a:p>
+            <a:pPr algn="l">
               <a:spcBef>
                 <a:spcPts val="500"/>
               </a:spcBef>
@@ -23629,27 +23452,11 @@
                 </a:solidFill>
                 <a:latin typeface="Calibri"/>
               </a:rPr>
-              <a:t>For numeric data, 'noise removal' means finding values that cannot be physical and handling them by a fixed, documented rule.</a:t>
-            </a:r>
-          </a:p>
-          <a:p>
-            <a:pPr>
-              <a:spcBef>
-                <a:spcPts val="500"/>
-              </a:spcBef>
-            </a:pPr>
-            <a:r>
-              <a:rPr sz="1300">
-                <a:solidFill>
-                  <a:srgbClr val="0B2A4A"/>
-                </a:solidFill>
-                <a:latin typeface="Calibri"/>
-              </a:rPr>
               <a:t>Rows are flagged rather than silently deleted, so the decision can be audited.</a:t>
             </a:r>
           </a:p>
           <a:p>
-            <a:pPr>
+            <a:pPr algn="l">
               <a:spcBef>
                 <a:spcPts val="500"/>
               </a:spcBef>

</xml_diff>